<commit_message>
feat: 更新圖像資源，替換 icon.pptx 和 preview.jpg
</commit_message>
<xml_diff>
--- a/assets/images/icon.pptx
+++ b/assets/images/icon.pptx
@@ -3340,7 +3340,7 @@
         </p:nvSpPr>
         <p:spPr>
           <a:xfrm>
-            <a:off x="1832897" y="297528"/>
+            <a:off x="1861472" y="316578"/>
             <a:ext cx="8540135" cy="6280253"/>
           </a:xfrm>
           <a:prstGeom prst="roundRect">
@@ -3385,8 +3385,9 @@
                 <a:solidFill>
                   <a:schemeClr val="tx1"/>
                 </a:solidFill>
-                <a:latin typeface="Neue Haas Grotesk D W0445" panose="020B0404020202020204" pitchFamily="34" charset="0"/>
-                <a:ea typeface="BIZ UDGothic" panose="020B0400000000000000" pitchFamily="33" charset="-128"/>
+                <a:latin typeface="Neue Haas Grotesk Text Pro" panose="020B0504020202020204" pitchFamily="34" charset="0"/>
+                <a:ea typeface="DejaVu Math TeX Gyre" panose="02000503000000000000" pitchFamily="2" charset="0"/>
+                <a:cs typeface="DejaVu Math TeX Gyre" panose="02000503000000000000" pitchFamily="2" charset="0"/>
               </a:rPr>
               <a:t>Rice</a:t>
             </a:r>
@@ -3395,8 +3396,9 @@
                 <a:solidFill>
                   <a:schemeClr val="tx1"/>
                 </a:solidFill>
-                <a:latin typeface="Neue Haas Grotesk D W0445" panose="020B0404020202020204" pitchFamily="34" charset="0"/>
+                <a:latin typeface="Neue Haas Grotesk Text Pro" panose="020B0504020202020204" pitchFamily="34" charset="0"/>
                 <a:ea typeface="BIZ UDGothic" panose="020B0400000000000000" pitchFamily="33" charset="-128"/>
+                <a:cs typeface="DejaVu Math TeX Gyre" panose="02000503000000000000" pitchFamily="2" charset="0"/>
               </a:rPr>
               <a:t> </a:t>
             </a:r>
@@ -3405,8 +3407,9 @@
                 <a:solidFill>
                   <a:schemeClr val="tx1"/>
                 </a:solidFill>
-                <a:latin typeface="Neue Haas Grotesk D W0445" panose="020B0404020202020204" pitchFamily="34" charset="0"/>
-                <a:ea typeface="BIZ UDGothic" panose="020B0400000000000000" pitchFamily="33" charset="-128"/>
+                <a:latin typeface="Neue Haas Grotesk Text Pro" panose="020B0504020202020204" pitchFamily="34" charset="0"/>
+                <a:ea typeface="DejaVu Math TeX Gyre" panose="02000503000000000000" pitchFamily="2" charset="0"/>
+                <a:cs typeface="DejaVu Math TeX Gyre" panose="02000503000000000000" pitchFamily="2" charset="0"/>
               </a:rPr>
               <a:t>Quality</a:t>
             </a:r>

</xml_diff>